<commit_message>
Presentation update for 2025-spring-harwell
</commit_message>
<xml_diff>
--- a/presentations/EPICS 7 Overview.pptx
+++ b/presentations/EPICS 7 Overview.pptx
@@ -252,7 +252,7 @@
           <a:p>
             <a:fld id="{E00E58FE-3AE1-4995-80E6-8AF0F1DA0E4E}" type="datetimeFigureOut">
               <a:rPr lang="de-DE" smtClean="0"/>
-              <a:t>16.09.2024</a:t>
+              <a:t>10.04.2025</a:t>
             </a:fld>
             <a:endParaRPr lang="de-DE"/>
           </a:p>
@@ -429,7 +429,7 @@
           <a:p>
             <a:fld id="{45091381-FB9B-4B1C-99E3-890DFD4525D3}" type="datetimeFigureOut">
               <a:rPr lang="de-DE" smtClean="0"/>
-              <a:t>16.09.2024</a:t>
+              <a:t>10.04.2025</a:t>
             </a:fld>
             <a:endParaRPr lang="de-DE"/>
           </a:p>
@@ -1309,7 +1309,7 @@
           <a:p>
             <a:fld id="{77B9AAF2-2243-4209-A85C-F7036AF186DC}" type="datetimeFigureOut">
               <a:rPr lang="de-DE" smtClean="0"/>
-              <a:t>16.09.2024</a:t>
+              <a:t>10.04.2025</a:t>
             </a:fld>
             <a:endParaRPr lang="de-DE"/>
           </a:p>
@@ -1547,7 +1547,7 @@
           <a:p>
             <a:fld id="{77B9AAF2-2243-4209-A85C-F7036AF186DC}" type="datetimeFigureOut">
               <a:rPr lang="de-DE" smtClean="0"/>
-              <a:t>16.09.2024</a:t>
+              <a:t>10.04.2025</a:t>
             </a:fld>
             <a:endParaRPr lang="de-DE"/>
           </a:p>
@@ -1785,7 +1785,7 @@
           <a:p>
             <a:fld id="{77B9AAF2-2243-4209-A85C-F7036AF186DC}" type="datetimeFigureOut">
               <a:rPr lang="de-DE" smtClean="0"/>
-              <a:t>16.09.2024</a:t>
+              <a:t>10.04.2025</a:t>
             </a:fld>
             <a:endParaRPr lang="de-DE"/>
           </a:p>
@@ -2023,7 +2023,7 @@
           <a:p>
             <a:fld id="{77B9AAF2-2243-4209-A85C-F7036AF186DC}" type="datetimeFigureOut">
               <a:rPr lang="de-DE" smtClean="0"/>
-              <a:t>16.09.2024</a:t>
+              <a:t>10.04.2025</a:t>
             </a:fld>
             <a:endParaRPr lang="de-DE"/>
           </a:p>
@@ -2328,7 +2328,7 @@
           <a:p>
             <a:fld id="{77B9AAF2-2243-4209-A85C-F7036AF186DC}" type="datetimeFigureOut">
               <a:rPr lang="de-DE" smtClean="0"/>
-              <a:t>16.09.2024</a:t>
+              <a:t>10.04.2025</a:t>
             </a:fld>
             <a:endParaRPr lang="de-DE"/>
           </a:p>
@@ -2631,7 +2631,7 @@
           <a:p>
             <a:fld id="{77B9AAF2-2243-4209-A85C-F7036AF186DC}" type="datetimeFigureOut">
               <a:rPr lang="de-DE" smtClean="0"/>
-              <a:t>16.09.2024</a:t>
+              <a:t>10.04.2025</a:t>
             </a:fld>
             <a:endParaRPr lang="de-DE"/>
           </a:p>
@@ -3082,7 +3082,7 @@
           <a:p>
             <a:fld id="{77B9AAF2-2243-4209-A85C-F7036AF186DC}" type="datetimeFigureOut">
               <a:rPr lang="de-DE" smtClean="0"/>
-              <a:t>16.09.2024</a:t>
+              <a:t>10.04.2025</a:t>
             </a:fld>
             <a:endParaRPr lang="de-DE"/>
           </a:p>
@@ -3255,7 +3255,7 @@
           <a:p>
             <a:fld id="{77B9AAF2-2243-4209-A85C-F7036AF186DC}" type="datetimeFigureOut">
               <a:rPr lang="de-DE" smtClean="0"/>
-              <a:t>16.09.2024</a:t>
+              <a:t>10.04.2025</a:t>
             </a:fld>
             <a:endParaRPr lang="de-DE"/>
           </a:p>
@@ -3629,7 +3629,7 @@
           <a:p>
             <a:fld id="{77B9AAF2-2243-4209-A85C-F7036AF186DC}" type="datetimeFigureOut">
               <a:rPr lang="de-DE" smtClean="0"/>
-              <a:t>16.09.2024</a:t>
+              <a:t>10.04.2025</a:t>
             </a:fld>
             <a:endParaRPr lang="de-DE"/>
           </a:p>
@@ -3950,7 +3950,7 @@
           <a:p>
             <a:fld id="{77B9AAF2-2243-4209-A85C-F7036AF186DC}" type="datetimeFigureOut">
               <a:rPr lang="de-DE" smtClean="0"/>
-              <a:t>16.09.2024</a:t>
+              <a:t>10.04.2025</a:t>
             </a:fld>
             <a:endParaRPr lang="de-DE"/>
           </a:p>
@@ -5404,7 +5404,7 @@
         <p:spPr>
           <a:xfrm>
             <a:off x="1314628" y="456623"/>
-            <a:ext cx="9283883" cy="4732578"/>
+            <a:ext cx="9283883" cy="4363246"/>
           </a:xfrm>
           <a:prstGeom prst="rect">
             <a:avLst/>
@@ -5585,7 +5585,29 @@
                 <a:ea typeface="Milo-Medium"/>
                 <a:cs typeface="Source Sans Pro"/>
               </a:rPr>
-              <a:t>Secure communication, using prototypes of client and server, is working</a:t>
+              <a:t>Secure </a:t>
+            </a:r>
+            <a:r>
+              <a:rPr lang="en-GB" sz="2400">
+                <a:solidFill>
+                  <a:srgbClr val="60737F"/>
+                </a:solidFill>
+                <a:latin typeface="Source Sans Pro"/>
+                <a:ea typeface="Milo-Medium"/>
+                <a:cs typeface="Source Sans Pro"/>
+              </a:rPr>
+              <a:t>communication itself </a:t>
+            </a:r>
+            <a:r>
+              <a:rPr lang="en-GB" sz="2400" dirty="0">
+                <a:solidFill>
+                  <a:srgbClr val="60737F"/>
+                </a:solidFill>
+                <a:latin typeface="Source Sans Pro"/>
+                <a:ea typeface="Milo-Medium"/>
+                <a:cs typeface="Source Sans Pro"/>
+              </a:rPr>
+              <a:t>is working</a:t>
             </a:r>
           </a:p>
           <a:p>
@@ -5611,7 +5633,7 @@
                 <a:ea typeface="Milo-Medium"/>
                 <a:cs typeface="Source Sans Pro"/>
               </a:rPr>
-              <a:t>The hard part, i.e. key management, is in its design phase</a:t>
+              <a:t>The hard part, i.e. key management, has a working prototype</a:t>
             </a:r>
           </a:p>
         </p:txBody>
@@ -9569,7 +9591,29 @@
                 <a:ea typeface="Milo-Medium"/>
                 <a:cs typeface="Source Sans Pro"/>
               </a:rPr>
-              <a:t>The Archiver Appliance always searches on both protocols to provide consistent archive data across migration</a:t>
+              <a:t>The </a:t>
+            </a:r>
+            <a:r>
+              <a:rPr lang="en-GB" sz="2400" dirty="0" err="1">
+                <a:solidFill>
+                  <a:srgbClr val="60737F"/>
+                </a:solidFill>
+                <a:latin typeface="Source Sans Pro"/>
+                <a:ea typeface="Milo-Medium"/>
+                <a:cs typeface="Source Sans Pro"/>
+              </a:rPr>
+              <a:t>Databrowser</a:t>
+            </a:r>
+            <a:r>
+              <a:rPr lang="en-GB" sz="2400" dirty="0">
+                <a:solidFill>
+                  <a:srgbClr val="60737F"/>
+                </a:solidFill>
+                <a:latin typeface="Source Sans Pro"/>
+                <a:ea typeface="Milo-Medium"/>
+                <a:cs typeface="Source Sans Pro"/>
+              </a:rPr>
+              <a:t> always searches on both protocols to provide consistent data across migration</a:t>
             </a:r>
           </a:p>
         </p:txBody>

</xml_diff>